<commit_message>
docs: midterm deck updated to the v3 build (date 2026-10-15, final numbers, second-midterm VLM line)
Co-authored-by: Munira <munira@knu.ac.kr>
</commit_message>
<xml_diff>
--- a/docs/midterm/ADVS_midterm.pptx
+++ b/docs/midterm/ADVS_midterm.pptx
@@ -181,11 +181,11 @@
                 </c:pt>
                 <c:pt idx="1">
                   <c:v>스캔 PDF
-741/790</c:v>
+779/790</c:v>
                 </c:pt>
                 <c:pt idx="2">
                   <c:v>사진 이미지
-752/790</c:v>
+785/790</c:v>
                 </c:pt>
               </c:strCache>
             </c:strRef>
@@ -200,10 +200,10 @@
                   <c:v>100</c:v>
                 </c:pt>
                 <c:pt idx="1">
-                  <c:v>93.8</c:v>
+                  <c:v>98.6</c:v>
                 </c:pt>
                 <c:pt idx="2">
-                  <c:v>95.2</c:v>
+                  <c:v>99.4</c:v>
                 </c:pt>
               </c:numCache>
             </c:numRef>
@@ -576,12 +576,11 @@
 (전부 사람 확인)</c:v>
                 </c:pt>
                 <c:pt idx="1">
-                  <c:v>Phase D
-(안전 규칙 강화 전)</c:v>
+                  <c:v>D2 (v2 빌드)</c:v>
                 </c:pt>
                 <c:pt idx="2">
-                  <c:v>D2 최종
-(현재)</c:v>
+                  <c:v>D3 병합
+(v3, 현재)</c:v>
                 </c:pt>
               </c:strCache>
             </c:strRef>
@@ -596,10 +595,10 @@
                   <c:v>11.64</c:v>
                 </c:pt>
                 <c:pt idx="1">
-                  <c:v>3.82</c:v>
+                  <c:v>7.23</c:v>
                 </c:pt>
                 <c:pt idx="2">
-                  <c:v>7.23</c:v>
+                  <c:v>3.73</c:v>
                 </c:pt>
               </c:numCache>
             </c:numRef>
@@ -634,12 +633,11 @@
 (전부 사람 확인)</c:v>
                 </c:pt>
                 <c:pt idx="1">
-                  <c:v>Phase D
-(안전 규칙 강화 전)</c:v>
+                  <c:v>D2 (v2 빌드)</c:v>
                 </c:pt>
                 <c:pt idx="2">
-                  <c:v>D2 최종
-(현재)</c:v>
+                  <c:v>D3 병합
+(v3, 현재)</c:v>
                 </c:pt>
               </c:strCache>
             </c:strRef>
@@ -654,10 +652,10 @@
                   <c:v>11.64</c:v>
                 </c:pt>
                 <c:pt idx="1">
-                  <c:v>3.55</c:v>
+                  <c:v>6.59</c:v>
                 </c:pt>
                 <c:pt idx="2">
-                  <c:v>6.59</c:v>
+                  <c:v>3.09</c:v>
                 </c:pt>
               </c:numCache>
             </c:numRef>
@@ -1452,7 +1450,7 @@
           <a:p/>
           <a:p>
             <a:r>
-              <a:t>결과 상세입니다. 왼쪽은 디지털 PDF의 필드 정확도로 개발 세트 240개 중 240개, hold-out 1은 275개 중 275개, 한 번만 판정한 hold-out 2도 275개 중 275개입니다. 가운데는 안전 지표로, 제출 가능이 아니어야 하는 제출 40건 중 거짓 제출 가능은 0건이고 95퍼센트 상한은 7.5퍼센트입니다. 주입한 오류 시험은 474건과 666건에서 0건입니다. 오른쪽은 스캔과 사진에서 사람이 확인할 항목으로 기준선 11.64개, Phase D 3.82개와 3.55개, 현재 7.23개와 6.59개입니다. 안전 규칙을 강화하면서 늘어난 것이며 소유자가 승인했습니다.</a:t>
+              <a:t>결과 상세입니다. 왼쪽은 디지털 PDF의 필드 정확도로 개발 세트 240개 중 240개, hold-out 1은 275개 중 275개, 한 번만 판정한 hold-out 2도 275개 중 275개입니다. 가운데는 안전 지표로, 제출 가능이 아니어야 하는 제출 40건 중 거짓 제출 가능은 0건이고 95퍼센트 상한은 7.5퍼센트입니다. 주입한 오류 시험은 개발 1,354건, hold-out 1 1,532건, hold-out 3 1,525건에서 0건이고 hold-out 2의 1,523건 중 알려진 H14 사례 1건이 있습니다. 오른쪽은 스캔과 사진에서 사람이 확인할 항목으로 기준선 11.64개, v2 빌드 7.23개와 6.59개, 현재 3.73개와 3.09개입니다.</a:t>
             </a:r>
           </a:p>
           <a:p/>
@@ -1463,7 +1461,7 @@
           </a:p>
           <a:p>
             <a:r>
-              <a:t>Left: digital extraction 240/240 (development), 275/275 (hold-out 1), 275/275 (hold-out 2, judged once). Middle: 0 false 'ready to submit' in 40 not-ready submissions per input type (95% upper bound 7.5%), 0 of 474 and 0 of 666 injected cases. Right: review fields per scanned submission 11.64 (baseline), 3.82/3.55 (Phase D, before the safety rules), 7.23/6.59 (now); the rise comes from tightening the safety rules, approved by the owner.</a:t>
+              <a:t>Left: digital extraction 240/240 (development), 275/275 (hold-out 1), 275/275 (hold-out 2, judged once). Middle: 0 false 'ready to submit' in 40 not-ready submissions per input type (95% upper bound 7.5%), injected cases: 0 of 1,354 (development), 0 of 1,532 (hold-out 1), 0 of 1,525 (hold-out 3) and 1 of 1,523 on hold-out 2 (the known H14 case). Right: review fields per scanned submission 11.64 (baseline), 7.23/6.59 (v2 build), 3.73/3.09 (v3, with D3 merged).</a:t>
             </a:r>
           </a:p>
         </p:txBody>
@@ -1626,7 +1624,7 @@
           <a:p/>
           <a:p>
             <a:r>
-              <a:t>데모 순서 (DEMO_SCRIPT.md v2). 시작 전 make demo, 발표 당일 아침에는 make demo-rehearsal로 점검합니다. 점검 기준일 2026-10-05는 바꾸지 않습니다.</a:t>
+              <a:t>데모 순서 (DEMO_SCRIPT.md v3, 태그 midterm-demo-v3). 시작 전 make demo, 발표 당일 아침에는 make demo-rehearsal로 점검합니다. 점검 기준일 2026-10-05는 바꾸지 않습니다.</a:t>
             </a:r>
           </a:p>
           <a:p>
@@ -1661,7 +1659,7 @@
           </a:p>
           <a:p>
             <a:r>
-              <a:t>7) D6 스캔 + 사람 확인: 확인 필요 · 4개. 크롭된 원본에서 라벨과 값을 확인하고 원본과 같음 · 확인(Enter)을 네 번 누르면 진행률이 4/4가 되고, 자동으로 제출 가능으로 바뀝니다. 자동 점검 버튼을 누를 필요가 없습니다.</a:t>
+              <a:t>7) D6 스캔(자동 확인): 깨끗한 스캔은 이제 사람 없이 제출 가능입니다. 8) D9 스캔 + 사람 확인: 확인 필요 · 2개. 크롭된 원본에서 두 발급일을 확인하고 원본과 같음 · 확인(Enter)을 두 번 누르면 진행률이 2/2가 되고, 자동으로 제출 가능으로 바뀝니다. 자동 점검 버튼을 누를 필요가 없습니다.</a:t>
             </a:r>
           </a:p>
           <a:p>
@@ -1671,7 +1669,7 @@
           </a:p>
           <a:p>
             <a:r>
-              <a:t>문제가 생기면: 탭을 새로고침 → 그래도 이상하면 make demo-reset(약 2분) → 아무것도 안 뜨면 make demo-stop &amp;&amp; make demo → 복구가 안 되면 이 슬라이드의 스크린샷(docs/midterm/screenshots_v2)으로 설명합니다. 이전 버전으로 되돌리려면 태그 midterm-demo-2026-10-14.</a:t>
+              <a:t>문제가 생기면: 탭을 새로고침 → 그래도 이상하면 make demo-reset(약 2분) → 아무것도 안 뜨면 make demo-stop &amp;&amp; make demo → 복구가 안 되면 이 슬라이드의 스크린샷(docs/midterm/screenshots_v3)으로 설명합니다. 이전 버전으로 되돌리려면 태그 midterm-demo-v2 (DEMO_SCRIPT_v2.md).</a:t>
             </a:r>
           </a:p>
           <a:p/>
@@ -1682,7 +1680,7 @@
           </a:p>
           <a:p>
             <a:r>
-              <a:t>Demo order follows DEMO_SCRIPT.md (v2): list, D1 (ready, evidence on the page), D2 (expired date and how to fix), optionally D3/D4 and D8 (inline upload), D5 (look-alike held for review), D6 (four values confirmed with Enter, status changes to ready by itself). Avoid changing the check date, real documents, the empty admin app, and the word 'official'. If something goes wrong: reload, then make demo-reset (about 2 minutes), then make demo-stop &amp;&amp; make demo, otherwise explain from the screenshots in docs/midterm/screenshots_v2; the previous version is tag midterm-demo-2026-10-14.</a:t>
+              <a:t>Demo order follows DEMO_SCRIPT.md (v3, tag midterm-demo-v3): list, D1 (ready, evidence on the page), D2 (expired date and how to fix), optionally D3/D4 and D8 (inline upload), D5 (look-alike held for review), D6 (a clean scan is now decided without a person) and D9 (two issue dates confirmed with Enter, status changes to ready by itself). Avoid changing the check date, real documents, the empty admin app, and the word 'official'. If something goes wrong: reload, then make demo-reset (about 2 minutes), then make demo-stop &amp;&amp; make demo, otherwise explain from the screenshots in docs/midterm/screenshots_v3; the previous version is tag midterm-demo-v2.</a:t>
             </a:r>
           </a:p>
         </p:txBody>
@@ -1932,7 +1930,7 @@
           <a:p/>
           <a:p>
             <a:r>
-              <a:t>11월과 12월 계획의 상세입니다. 각 작업에는 완료를 재는 방법이 있습니다. D3는 개발 데이터에서 판단을 막는 확인 항목을 5.41개에서 2.68개로 줄였지만 아직 합치지 않았고, hold-out 3으로 한 번만 판정한 뒤에 결정합니다. VLM 시험을 한다면 별도 환경에서, 공식 요구 사항을 따라, 같은 문서로 비교합니다. 개발용 Mac에는 NVIDIA GPU가 없어서 CPU나 MLX 실행을 측정하거나 외부 GPU가 필요합니다. 12월 관문의 네 가지 조건을 모두 만족할 때만 채택하고, 아니면 현재 구조를 유지합니다.</a:t>
+              <a:t>11월과 12월 계획의 상세입니다. 각 작업에는 완료를 재는 방법이 있습니다. D3는 합쳤고 hold-out 3으로 한 번만 판정했습니다. 스캔 제출 1건당 확인 항목은 7.68개에서 4.28개로 줄었고 거짓 제출 가능은 0건입니다. VLM 시험을 한다면 별도 환경에서, 공식 요구 사항을 따라, 같은 문서로 비교합니다. 개발용 Mac에는 NVIDIA GPU가 없어서 CPU나 MLX 실행을 측정하거나 외부 GPU가 필요합니다. 12월 관문의 네 가지 조건을 모두 만족할 때만 채택하고, 아니면 현재 구조를 유지합니다.</a:t>
             </a:r>
           </a:p>
           <a:p/>
@@ -1943,7 +1941,7 @@
           </a:p>
           <a:p>
             <a:r>
-              <a:t>Detailed November/December plan with a completion measure per task. D3 (unmerged, in progress) cut decision-blocking review fields from 5.41 to 2.68 on development data and is judged once on hold-out 3 before any merge. A VLM trial would use an isolated environment (paddlepaddle(-gpu) &gt;= 3.2.1, paddleocr[doc-parser] &gt;= 3.4.0, an NVIDIA GPU with CC &gt;= 7.0, vLLM &gt;= 8.0, or a measured CPU/MLX run); the development Mac (M3 Pro, 18 GB) has no NVIDIA GPU. Adoption only if all four December gate conditions hold.</a:t>
+              <a:t>Detailed November/December plan with a completion measure per task. D3 is merged and was judged once on hold-out 3: review fields per scanned submission fell from 7.68 to 4.28, with 0 false 'ready to submit' (n=14, upper bound 21%). A VLM trial would use an isolated environment (paddlepaddle(-gpu) &gt;= 3.2.1, paddleocr[doc-parser] &gt;= 3.4.0, an NVIDIA GPU with CC &gt;= 7.0, vLLM &gt;= 8.0, or a measured CPU/MLX run); the development Mac (M3 Pro, 18 GB) has no NVIDIA GPU. Adoption only if all four December gate conditions hold.</a:t>
             </a:r>
           </a:p>
         </p:txBody>
@@ -2019,7 +2017,7 @@
           <a:p/>
           <a:p>
             <a:r>
-              <a:t>발표를 들어 주셔서 감사합니다. 예상 질문과 답입니다. 실제 서류에서도 되는지는 가상 서류로만 시험했고 실사진 말뭉치와 파일럿이 다음 단계입니다. PDF 위조는 현재 글자층을 검증 없이 믿는 구멍을 확인했고 11월에 신뢰 점검을 추가합니다. LLM이나 VLM을 쓰지 않은 이유는 측정한 근거가 없기 때문이며, 11월에 비교해서 12월에 결정합니다. 0건이 안전하다는 뜻이냐는 질문에는, 40건 중 0건의 95퍼센트 상한이 7.5퍼센트라고 답합니다.</a:t>
+              <a:t>발표를 들어 주셔서 감사합니다. 예상 질문과 답입니다. 실제 서류에서도 되는지는 가상 서류로만 시험했고 실사진 말뭉치와 파일럿이 다음 단계입니다. PDF 위조는 숨은 글자를 읽지 않고 확인 필요로 표시하도록 고쳤고, 위·변조 여부 자체는 발급기관 확인이 필요합니다. LLM이나 VLM은 아직 통합하지 않았고, 2차 중간발표에서 같은 데이터로 비교해서 12월에 결정합니다. 0건이 안전하다는 뜻이냐는 질문에는, 40건 중 0건의 95퍼센트 상한이 7.5퍼센트라고 답합니다.</a:t>
             </a:r>
           </a:p>
           <a:p/>
@@ -2030,7 +2028,7 @@
           </a:p>
           <a:p>
             <a:r>
-              <a:t>Prepared answers: real documents (not yet tested; physical corpus and pilot next); forged PDFs (a verified gap, fix planned, authenticity itself needs issuer verification); why no LLM/VLM (no measured evidence, compare in November, decide in December); does zero failures mean safe (no: the 95% upper bound for 0/40 is 7.5%).</a:t>
+              <a:t>Prepared answers: real documents (not yet tested; physical corpus and pilot next); forged PDFs (hidden text is now ignored and flagged, 0 of 705 manipulated copies missed; authenticity itself needs issuer verification); why no LLM/VLM (not integrated yet; compared on the same data for the second midterm, decision in December); does zero failures mean safe (no: the 95% upper bound for 0/40 is 7.5%).</a:t>
             </a:r>
           </a:p>
         </p:txBody>
@@ -2193,7 +2191,7 @@
           <a:p/>
           <a:p>
             <a:r>
-              <a:t>멘토님이 정의하신 서류 6종, 기업 4종과 학생 2종을 구현했습니다. 흐름은 한 줄입니다. 업로드, 텍스트 읽기, 분류, 추출과 근거 기록, 자동 수용 정책, 규칙 점검, 상태와 사람 검토입니다. 디지털 PDF는 글자층을 읽고 스캔과 사진은 PaddleOCR로 읽습니다. 구현 상태를 정직하게 표시했습니다. 녹색은 가상 데이터로 구현하고 검증한 부분, 주황색은 부분 구현입니다. 사진 전처리는 방향과 파일 형식 변환뿐이고, D3는 구현됐지만 아직 합치지 않았습니다. 점선 상자는 계획이며 아직 구현하지 않았습니다. 특히 현재 시스템에는 LLM이나 VLM이 없고, 모든 판단은 규칙과 증거로 합니다.</a:t>
+              <a:t>멘토님이 정의하신 서류 6종, 기업 4종과 학생 2종을 구현했습니다. 흐름은 한 줄입니다. 업로드, 텍스트 읽기, 분류, 추출과 근거 기록, 자동 수용 정책, 규칙 점검, 상태와 사람 검토입니다. 디지털 PDF는 글자층을 읽고 스캔과 사진은 PaddleOCR로 읽습니다. 구현 상태를 정직하게 표시했습니다. 녹색은 가상 데이터로 구현하고 검증한 부분, 주황색은 부분 구현입니다. 사진 전처리는 방향과 파일 형식 변환뿐입니다. D3는 합쳤고, PDF 글자층은 눈에 보이는 글자만 신뢰하도록 고쳤습니다. 점선 상자는 계획이며 아직 구현하지 않았습니다. 특히 현재 시스템에는 LLM이나 VLM이 없고, 모든 판단은 규칙과 증거로 합니다.</a:t>
             </a:r>
           </a:p>
           <a:p/>
@@ -2204,7 +2202,7 @@
           </a:p>
           <a:p>
             <a:r>
-              <a:t>Six mentor-defined documents (four business, two student) and one pipeline. Green = implemented and verified on synthetic data; amber = partial (photo preprocessing is EXIF and codec only; D3 is built but unmerged); dashed = planned or proposed (text-layer trust check, photo quality gate, a second reader such as PaddleOCR-VL, login). The current system contains no LLM or VLM.</a:t>
+              <a:t>Six mentor-defined documents (four business, two student) and one pipeline. Green = implemented and verified on synthetic data; amber = partial (photo preprocessing is EXIF and codec only; D3 internal confirmation is merged and judged once on hold-out 3; the PDF text layer is now trusted only for visible text); dashed = planned or proposed (photo quality gate, a second reader such as PaddleOCR-VL, login). The current system contains no LLM or VLM.</a:t>
             </a:r>
           </a:p>
         </p:txBody>
@@ -2367,7 +2365,7 @@
           <a:p/>
           <a:p>
             <a:r>
-              <a:t>시험 방법입니다. 실제 서류 양식 7종을 바탕으로 만든 가상 서류 299개 파일과 279개씩의 hold-out 세트 두 개를 사용했고, 채점기는 고정했으며, OCR 오독을 일부러 넣는 오류 주입 시험을 했습니다. 결과입니다. 왼쪽 차트는 인식과 추출 결과의 필드 정확도로, 디지털 PDF는 790개 중 790개, 스캔은 741개, 사진은 752개가 맞았고 틀린 값은 세 경우 모두 0개였습니다. 가장 중요한 안전 지표는 잘못된 제출 가능입니다. 제출 가능이 아니어야 하는 제출 40건 중 0건이었지만, 표본이 작아 95퍼센트 신뢰 상한은 7.5퍼센트입니다. 주입한 오류 시험에서는 474건과 666건 중 0건입니다. 이 사례들은 같은 원본 서류에서 만들어져 상한이 낙관적입니다. 사람이 확인하는 항목은 스캔·사진에서 38~43퍼센트 줄었습니다. 모두 가상 서류 결과이고, 실제 서류의 위험은 측정하지 않았습니다.</a:t>
+              <a:t>시험 방법입니다. 실제 서류 양식 7종을 바탕으로 만든 가상 서류 299개 파일과 279개씩의 hold-out 세트 두 개를 사용했고, 채점기는 고정했으며, OCR 오독을 일부러 넣는 오류 주입 시험을 했습니다. 결과입니다. 왼쪽 차트는 인식과 추출 결과의 필드 정확도로, 디지털 PDF는 790개 중 790개, 스캔은 779개, 사진은 785개가 맞았고 틀린 값은 세 경우 모두 0개였습니다. 한 번만 판정한 hold-out 3에서도 스캔 268/275, 사진 273/275, 틀린 값 0개입니다. 가장 중요한 안전 지표는 잘못된 제출 가능입니다. 제출 가능이 아니어야 하는 제출 40건 중 0건이었지만, 표본이 작아 95퍼센트 신뢰 상한은 7.5퍼센트입니다. hold-out 3에서도 거짓 제출 가능은 0건입니다. 주입한 오류 시험은 개발 1,354건, hold-out 1 1,532건, hold-out 3 1,525건에서 0건이고, hold-out 2의 1,523건 중 1건만 알려진 잔여 위험(H14)이며 소유자가 승인했습니다. 이 사례들은 같은 원본 서류에서 만들어져 상한이 낙관적입니다. 사람이 확인하는 항목은 스캔·사진에서 68~73퍼센트 줄었습니다. 모두 가상 서류 결과이고, 실제 서류의 위험은 측정하지 않았습니다.</a:t>
             </a:r>
           </a:p>
           <a:p/>
@@ -2378,7 +2376,7 @@
           </a:p>
           <a:p>
             <a:r>
-              <a:t>Method: 299 + 279 + 279 fictional files, a frozen scorer, injected OCR errors, hold-out judged once. Field accuracy: digital 790/790, scans 741/790, photos 752/790, with 0 wrong values. False 'ready to submit': 0 of 40 not-ready submissions per input type (95% upper bound 7.5%); 0 of 474 and 0 of 666 injected cases (bounds 0.63% and 0.45%, optimistic because cases share base documents). Manual checking on scans fell 38–43%. Everything is synthetic; real-world risk is not measured.</a:t>
+              <a:t>Method: 299 + 279 + 279 fictional files, a frozen scorer, injected OCR errors, hold-out judged once. Field accuracy: digital 790/790, scans 779/790, photos 785/790, with 0 wrong values (hold-out 3, judged once: scans 268/275, photos 273/275, 0 wrong). False 'ready to submit': 0 of 40 not-ready submissions per input type (95% upper bound 7.5%) on development data and 0 of 14 on hold-out 3; injected errors: 0 of 1,354, 0 of 1,532 and 0 of 1,525, and 1 of 1,523 on hold-out 2 (the known H14 residual risk, accepted by the owner; bounds about 0.2%, optimistic because cases share base documents). Manual checking on scans fell 68–73%. Everything is synthetic; real-world risk is not measured.</a:t>
             </a:r>
           </a:p>
         </p:txBody>
@@ -2454,7 +2452,7 @@
           <a:p/>
           <a:p>
             <a:r>
-              <a:t>한계를 말씀드립니다. 먼저 중요한 관찰입니다. 가상 데이터에서 OCR은 숫자와 날짜를 거의 정확히 읽습니다. 사업자등록번호는 스캔에서 160개 중 160개, 날짜는 212개 중 208개입니다. 그런데 스캔 제출 22건 중 사람 없이 끝난 것은 1건뿐입니다. OCR이 틀릴 수 있는데 그 값이 맞다는 독립적인 증거가 없으면 자동 수용하지 않는 정책 때문입니다. 병목은 인식이 아니라 확인입니다. 두 번째는 학생 서류에서 대학명이 스캔 58개 중 21개만 맞는 추출 결함입니다. 세 번째는 모든 데이터가 가상이고 깨끗하다는 점입니다. 네 번째는 이번 점검에서 직접 확인한 보안 한계입니다. PDF 글자층을 검증 없이 믿기 때문에 숨은 텍스트가 화면과 다른 날짜를 담고 있어도 그대로 읽습니다. 시연 서류에는 영향이 없지만 11월에 수정합니다. 마지막으로 SQLite로만 시험했고 로그인이 없습니다.</a:t>
+              <a:t>한계를 말씀드립니다. 먼저 중요한 관찰입니다. 가상 데이터에서 OCR은 숫자와 날짜를 거의 정확히 읽습니다. 사업자등록번호는 스캔에서 160개 중 160개, 날짜는 212개 중 208개입니다. 그래도 스캔 제출 22건 중 사람 없이 끝난 것은 4건입니다. OCR이 틀릴 수 있는데 그 값이 맞다는 독립적인 증거가 없으면 자동 수용하지 않는 정책 때문입니다. 병목은 인식이 아니라 확인입니다. 이번에 두 가지를 고쳤습니다. 학생 서류의 대학명은 스캔 58개 중 21개에서 56개로 올랐고, PDF의 숨은 글자는 더 이상 믿지 않고 확인 필요로 표시합니다. 남은 한계는 모든 데이터가 가상이고 깨끗하다는 점, 알려진 잔여 위험인 H14 사례, 그리고 SQLite로만 시험했고 로그인이 없다는 점입니다. hold-out 3은 한 번만 판정했습니다.</a:t>
             </a:r>
           </a:p>
           <a:p/>
@@ -2465,7 +2463,7 @@
           </a:p>
           <a:p>
             <a:r>
-              <a:t>Key observation: on synthetic data OCR reads digits and dates almost perfectly (business number 160/160 on scans, dates 208/212), yet only 1 of 22 scanned submissions finishes without a person because values need independent confirmation: the bottleneck is confirmation, not recognition. Other limits: scanned university_name extraction (21/58), all data synthetic and clean, a verified gap where the PDF text layer is trusted (hidden text overrides the visible date; fix planned for November), SQLite only, no login, hold-out 3 not yet judged.</a:t>
+              <a:t>Key observation: on synthetic data OCR reads digits and dates almost perfectly (business number 160/160 on scans, dates 208/212), yet only 4 of 22 scanned submissions finish without a person because values need independent confirmation: the bottleneck is confirmation, not recognition. Fixed in this build: scanned university_name 21/58 to 56/58, and hidden PDF text is no longer trusted (flagged for review; 0 of 705 manipulated copies missed). Remaining limits: all data synthetic and clean, the known H14 residual risk (accepted by the owner), SQLite only, no login. Hold-out 3 was judged once.</a:t>
             </a:r>
           </a:p>
         </p:txBody>
@@ -2628,7 +2626,7 @@
           <a:p/>
           <a:p>
             <a:r>
-              <a:t>계획입니다. 10월은 발표 빌드를 고정하고 문서를 코드와 일치시키며 한계를 기록합니다. 11월에는 분모와 신뢰 상한을 포함한 기준선을 측정하고, 확인된 결함인 PDF 글자층 신뢰 점검과 대학명 추출을 고치고, D3를 완성해 hold-out 3으로 한 번만 판정합니다. 검토자 화면과 관리자 화면, 실제 서류 파일럿도 합니다. 시간이 되면 PaddleOCR-VL을 격리된 환경에서 같은 문서로 비교합니다. 12월에는 그 증거로 VLM 채택 여부를 결정하고 로그인, 개인정보, 감사 로그, 전체 테스트와 배포를 마칩니다. 일정은 수업의 확정된 마감일에 맞추어 조정합니다. 결론입니다. ADVS의 강점은 가상 데이터에서 검증한 안전한 기권이고, 다음 단계는 모델을 더하는 것이 아니라 실제 데이터와 증거로 병목을 확인하는 것입니다. 감사합니다. [질의 2분: 부록 슬라이드 준비]</a:t>
+              <a:t>계획입니다. 10월에는 확인된 결함인 PDF 글자층 신뢰 점검과 대학명 추출을 고치고, D3를 합쳐 hold-out 3으로 한 번만 판정했으며, 발표 빌드 v3를 고정했습니다. 11월에는 분모와 신뢰 상한을 포함한 기준선을 측정하고 실사진 말뭉치와 검토자·관리자 화면, 실제 서류 파일럿을 합니다. 2차 중간발표에서는 PaddleOCR-VL 선택적 검증 실험을 기존 OCR과 같은 데이터로 비교합니다. 정확도, 오류 상관, 자동화 효과, 속도를 봅니다. 12월에는 그 증거로 VLM 채택 여부를 결정하고 로그인, 개인정보, 감사 로그, 전체 테스트와 배포를 마칩니다. 일정은 수업의 확정된 마감일에 맞추어 조정합니다. 결론입니다. ADVS의 강점은 가상 데이터에서 검증한 안전한 기권이고, 다음 단계는 모델을 더하는 것이 아니라 실제 데이터와 증거로 병목을 확인하는 것입니다. 감사합니다. [질의 2분: 부록 슬라이드 준비]</a:t>
             </a:r>
           </a:p>
           <a:p/>
@@ -2639,7 +2637,7 @@
           </a:p>
           <a:p>
             <a:r>
-              <a:t>October: freeze the demo build, align documents with code, record limits, start the physical corpus. November: baseline with denominators and bounds, text-layer trust check, university-name extraction fix, finish D3 and judge it once on hold-out 3, reviewer and admin screens, real-document pilot, optional isolated VLM comparison. December: decide on the VLM from evidence, login, privacy, audit log, end-to-end tests, deployment, final report. Conclusion: ADVS's strength is verified safe abstention on synthetic data; the next step is evidence, not another model. Dates follow the confirmed course deadlines.</a:t>
+              <a:t>October: text-layer trust check and university-name fix done, D3 merged and judged once on hold-out 3, demo build v3 frozen. November: baseline with denominators and bounds, physical corpus, reviewer and admin screens, real-document pilot. Second midterm: PaddleOCR-VL selective verification experiment compared with the current OCR on the same data (accuracy, error correlation, automation effect, speed). December: decide on the VLM from evidence, login, privacy, audit log, end-to-end tests, deployment, final report. Conclusion: ADVS's strength is verified safe abstention on synthetic data; the next step is evidence, not another model. Dates follow the confirmed course deadlines.</a:t>
             </a:r>
           </a:p>
         </p:txBody>
@@ -6240,7 +6238,7 @@
                 <a:cs typeface="Apple SD Gothic Neo"/>
                 <a:ea typeface="Apple SD Gothic Neo"/>
               </a:rPr>
-              <a:t>ADVS · 중간 발표 2026-10-14</a:t>
+              <a:t>ADVS · 중간 발표 2026-10-15</a:t>
             </a:r>
           </a:p>
         </p:txBody>
@@ -6984,7 +6982,7 @@
                 <a:cs typeface="Apple SD Gothic Neo"/>
                 <a:ea typeface="Apple SD Gothic Neo"/>
               </a:rPr>
-              <a:t>ADVS · 중간 발표 2026-10-14</a:t>
+              <a:t>ADVS · 중간 발표 2026-10-15</a:t>
             </a:r>
           </a:p>
         </p:txBody>
@@ -8004,7 +8002,7 @@
                 <a:cs typeface="Apple SD Gothic Neo"/>
                 <a:ea typeface="Apple SD Gothic Neo"/>
               </a:rPr>
-              <a:t>[부록] 결과 상세: 디지털 100%, 스캔·사진 사람 확인 38–43% 감소</a:t>
+              <a:t>[부록] 결과 상세: 디지털 100%, 스캔·사진 사람 확인 68–73% 감소</a:t>
             </a:r>
           </a:p>
         </p:txBody>
@@ -8086,7 +8084,7 @@
                 <a:cs typeface="Apple SD Gothic Neo"/>
                 <a:ea typeface="Apple SD Gothic Neo"/>
               </a:rPr>
-              <a:t>ADVS · 중간 발표 2026-10-14</a:t>
+              <a:t>ADVS · 중간 발표 2026-10-15</a:t>
             </a:r>
           </a:p>
         </p:txBody>
@@ -8258,7 +8256,7 @@
               </a:lnSpc>
             </a:pPr>
             <a:r>
-              <a:rPr sz="1300" b="0">
+              <a:rPr sz="1200" b="0">
                 <a:solidFill>
                   <a:srgbClr val="1B2433"/>
                 </a:solidFill>
@@ -8266,7 +8264,7 @@
                 <a:cs typeface="Apple SD Gothic Neo"/>
                 <a:ea typeface="Apple SD Gothic Neo"/>
               </a:rPr>
-              <a:t>주입 오류 0 / 474</a:t>
+              <a:t>주입 오류 0 / 1,354 · 0 / 1,532 · 0 / 1,525</a:t>
             </a:r>
           </a:p>
           <a:p>
@@ -8276,7 +8274,7 @@
               </a:lnSpc>
             </a:pPr>
             <a:r>
-              <a:rPr sz="1300" b="0">
+              <a:rPr sz="1200" b="0">
                 <a:solidFill>
                   <a:srgbClr val="1B2433"/>
                 </a:solidFill>
@@ -8284,7 +8282,7 @@
                 <a:cs typeface="Apple SD Gothic Neo"/>
                 <a:ea typeface="Apple SD Gothic Neo"/>
               </a:rPr>
-              <a:t>주입 오류 0 / 666</a:t>
+              <a:t>(hold-out 2: 1 / 1,523 = H14)</a:t>
             </a:r>
           </a:p>
           <a:p>
@@ -8364,7 +8362,7 @@
                 <a:cs typeface="Apple SD Gothic Neo"/>
                 <a:ea typeface="Apple SD Gothic Neo"/>
               </a:rPr>
-              <a:t>스캔·사진의 사람 확인은 11.64 → 7.23 / 6.59로 38–43% 감소. 안전 규칙을 강화해 Phase D(3.82 / 3.55)보다는 늘었고, 소유자가 이를 승인했습니다.</a:t>
+              <a:t>스캔·사진의 사람 확인은 11.64 → 3.73 / 3.09로 68–73% 감소 (v2 빌드는 7.23 / 6.59). D3의 독립 확인을 합쳤고, hold-out 3에서도 7.68 / 7.32 → 4.28 / 4.08입니다.</a:t>
             </a:r>
           </a:p>
         </p:txBody>
@@ -8557,7 +8555,7 @@
                 <a:cs typeface="Apple SD Gothic Neo"/>
                 <a:ea typeface="Apple SD Gothic Neo"/>
               </a:rPr>
-              <a:t>ADVS · 중간 발표 2026-10-14</a:t>
+              <a:t>ADVS · 중간 발표 2026-10-15</a:t>
             </a:r>
           </a:p>
         </p:txBody>
@@ -9179,7 +9177,7 @@
                 <a:cs typeface="Apple SD Gothic Neo"/>
                 <a:ea typeface="Apple SD Gothic Neo"/>
               </a:rPr>
-              <a:t>ADVS · 중간 발표 2026-10-14</a:t>
+              <a:t>ADVS · 중간 발표 2026-10-15</a:t>
             </a:r>
           </a:p>
         </p:txBody>
@@ -9619,14 +9617,14 @@
                 <a:cs typeface="Apple SD Gothic Neo"/>
                 <a:ea typeface="Apple SD Gothic Neo"/>
               </a:rPr>
-              <a:t>D6  스캔 + 사람 확인</a:t>
+              <a:t>D9  스캔 + 사람 확인</a:t>
             </a:r>
           </a:p>
         </p:txBody>
       </p:sp>
       <p:pic>
         <p:nvPicPr>
-          <p:cNvPr id="16" name="Picture 15" descr="thumb_D6.png"/>
+          <p:cNvPr id="16" name="Picture 15" descr="thumb_D9.png"/>
           <p:cNvPicPr>
             <a:picLocks noChangeAspect="1"/>
           </p:cNvPicPr>
@@ -9819,7 +9817,7 @@
                 <a:cs typeface="Apple SD Gothic Neo"/>
                 <a:ea typeface="Apple SD Gothic Neo"/>
               </a:rPr>
-              <a:t>D6  스캔 서류의 4개 항목을 원본과 비교해 확인 → 자동으로 제출 가능</a:t>
+              <a:t>D9  스캔 서류(학생)의 발급일 2개를 원본과 비교해 확인 → 자동으로 제출 가능 (D6 스캔은 사람 없이 제출 가능)</a:t>
             </a:r>
           </a:p>
         </p:txBody>
@@ -10053,7 +10051,7 @@
                 <a:cs typeface="Apple SD Gothic Neo"/>
                 <a:ea typeface="Apple SD Gothic Neo"/>
               </a:rPr>
-              <a:t>ADVS · 중간 발표 2026-10-14</a:t>
+              <a:t>ADVS · 중간 발표 2026-10-15</a:t>
             </a:r>
           </a:p>
         </p:txBody>
@@ -10293,7 +10291,7 @@
                           <a:cs typeface="Apple SD Gothic Neo"/>
                           <a:ea typeface="Apple SD Gothic Neo"/>
                         </a:rPr>
-                        <a:t>V 0/40, 0/474</a:t>
+                        <a:t>V 0/40, 0/1,354</a:t>
                       </a:r>
                     </a:p>
                   </a:txBody>
@@ -10853,7 +10851,7 @@
                           <a:cs typeface="Apple SD Gothic Neo"/>
                           <a:ea typeface="Apple SD Gothic Neo"/>
                         </a:rPr>
-                        <a:t>V 결함 실측, D3 일부</a:t>
+                        <a:t>V 글자층·대학명 수정, D3 병합</a:t>
                       </a:r>
                     </a:p>
                   </a:txBody>
@@ -10949,7 +10947,7 @@
                           <a:cs typeface="Apple SD Gothic Neo"/>
                           <a:ea typeface="Apple SD Gothic Neo"/>
                         </a:rPr>
-                        <a:t>문서화 · 먼저 · 유지</a:t>
+                        <a:t>구현됨 · 측정 확대 · 유지</a:t>
                       </a:r>
                     </a:p>
                   </a:txBody>
@@ -10999,7 +10997,7 @@
                           <a:cs typeface="Apple SD Gothic Neo"/>
                           <a:ea typeface="Apple SD Gothic Neo"/>
                         </a:rPr>
-                        <a:t>V D3 일부(미병합), 가상 데이터는 오류 적음</a:t>
+                        <a:t>V D3 병합, hold-out 3 판정 1회</a:t>
                       </a:r>
                     </a:p>
                   </a:txBody>
@@ -11023,7 +11021,7 @@
                           <a:cs typeface="Apple SD Gothic Neo"/>
                           <a:ea typeface="Apple SD Gothic Neo"/>
                         </a:rPr>
-                        <a:t>V 스트레스 시험에서 1건</a:t>
+                        <a:t>V 주입 1건(H14, 소유자 승인)</a:t>
                       </a:r>
                     </a:p>
                   </a:txBody>
@@ -11095,7 +11093,7 @@
                           <a:cs typeface="Apple SD Gothic Neo"/>
                           <a:ea typeface="Apple SD Gothic Neo"/>
                         </a:rPr>
-                        <a:t>안 함 · D3 판정 · 데이터 있을 때</a:t>
+                        <a:t>D3 완료 · 보정은 데이터 있을 때</a:t>
                       </a:r>
                     </a:p>
                   </a:txBody>
@@ -11145,7 +11143,7 @@
                           <a:cs typeface="Apple SD Gothic Neo"/>
                           <a:ea typeface="Apple SD Gothic Neo"/>
                         </a:rPr>
-                        <a:t>V 결함 직접 확인</a:t>
+                        <a:t>V 구현·검증 (조작 705건 중 0건 놓침)</a:t>
                       </a:r>
                     </a:p>
                   </a:txBody>
@@ -11169,7 +11167,7 @@
                           <a:cs typeface="Apple SD Gothic Neo"/>
                           <a:ea typeface="Apple SD Gothic Neo"/>
                         </a:rPr>
-                        <a:t>V 알려진 구멍을 막음</a:t>
+                        <a:t>V 숨은 글자 차단, 오경보 0/307쪽</a:t>
                       </a:r>
                     </a:p>
                   </a:txBody>
@@ -11193,7 +11191,7 @@
                           <a:cs typeface="Apple SD Gothic Neo"/>
                           <a:ea typeface="Apple SD Gothic Neo"/>
                         </a:rPr>
-                        <a:t>H 쪽당 렌더+OCR</a:t>
+                        <a:t>V 쪽당 수십 ms (OCR은 숨은 글자가 있을 때만)</a:t>
                       </a:r>
                     </a:p>
                   </a:txBody>
@@ -11241,7 +11239,7 @@
                           <a:cs typeface="Apple SD Gothic Neo"/>
                           <a:ea typeface="Apple SD Gothic Neo"/>
                         </a:rPr>
-                        <a:t>기록 · 먼저 · 유지</a:t>
+                        <a:t>구현됨 · 유지 · 유지</a:t>
                       </a:r>
                     </a:p>
                   </a:txBody>
@@ -11631,7 +11629,7 @@
                 <a:cs typeface="Apple SD Gothic Neo"/>
                 <a:ea typeface="Apple SD Gothic Neo"/>
               </a:rPr>
-              <a:t>ADVS · 중간 발표 2026-10-14</a:t>
+              <a:t>ADVS · 중간 발표 2026-10-15</a:t>
             </a:r>
           </a:p>
         </p:txBody>
@@ -11871,7 +11869,7 @@
                           <a:cs typeface="Apple SD Gothic Neo"/>
                           <a:ea typeface="Apple SD Gothic Neo"/>
                         </a:rPr>
-                        <a:t>790/790 · 741/790 · 752/790</a:t>
+                        <a:t>790/790 · 779/790 · 785/790 (v3)</a:t>
                       </a:r>
                     </a:p>
                   </a:txBody>
@@ -12021,7 +12019,7 @@
                           <a:cs typeface="Apple SD Gothic Neo"/>
                           <a:ea typeface="Apple SD Gothic Neo"/>
                         </a:rPr>
-                        <a:t>18/72 · 70/72 · 70/72</a:t>
+                        <a:t>18/72 · 64/72 · 61/72 (v3)</a:t>
                       </a:r>
                     </a:p>
                   </a:txBody>
@@ -12186,7 +12184,7 @@
                 <a:cs typeface="Apple SD Gothic Neo"/>
                 <a:ea typeface="Apple SD Gothic Neo"/>
               </a:rPr>
-              <a:t>개발용과 판정용 세트 분리: hold-out 3은 D3 판정용으로 열지 않음; 새 판정 세트는 튜닝하지 않는 사람이 만듦</a:t>
+              <a:t>개발용과 판정용 세트 분리: hold-out 3은 한 번만 판정함(완료); 새 판정 세트는 튜닝하지 않는 사람이 만듦</a:t>
             </a:r>
           </a:p>
           <a:p>
@@ -12445,7 +12443,7 @@
                 <a:cs typeface="Apple SD Gothic Neo"/>
                 <a:ea typeface="Apple SD Gothic Neo"/>
               </a:rPr>
-              <a:t>ADVS · 중간 발표 2026-10-14</a:t>
+              <a:t>ADVS · 중간 발표 2026-10-15</a:t>
             </a:r>
           </a:p>
         </p:txBody>
@@ -12587,7 +12585,7 @@
                           <a:cs typeface="Apple SD Gothic Neo"/>
                           <a:ea typeface="Apple SD Gothic Neo"/>
                         </a:rPr>
-                        <a:t>N2 PDF 글자층 신뢰 점검</a:t>
+                        <a:t>N2 PDF 글자층 신뢰 점검 (완료)</a:t>
                       </a:r>
                     </a:p>
                   </a:txBody>
@@ -12611,7 +12609,7 @@
                           <a:cs typeface="Apple SD Gothic Neo"/>
                           <a:ea typeface="Apple SD Gothic Neo"/>
                         </a:rPr>
-                        <a:t>조작 시험 통과, 정상 디지털 파일 오거부 0</a:t>
+                        <a:t>조작 705건 중 0건 놓침, 정상 307쪽 오경보 0</a:t>
                       </a:r>
                     </a:p>
                   </a:txBody>
@@ -12637,7 +12635,7 @@
                           <a:cs typeface="Apple SD Gothic Neo"/>
                           <a:ea typeface="Apple SD Gothic Neo"/>
                         </a:rPr>
-                        <a:t>N3 대학명 추출 수정</a:t>
+                        <a:t>N3 대학명 추출 수정 (완료)</a:t>
                       </a:r>
                     </a:p>
                   </a:txBody>
@@ -12661,7 +12659,7 @@
                           <a:cs typeface="Apple SD Gothic Neo"/>
                           <a:ea typeface="Apple SD Gothic Neo"/>
                         </a:rPr>
-                        <a:t>같은 문서에서 수정 전후 비교</a:t>
+                        <a:t>스캔 21/58 → 56/58, 사진 24/58 → 57/58</a:t>
                       </a:r>
                     </a:p>
                   </a:txBody>
@@ -12687,7 +12685,7 @@
                           <a:cs typeface="Apple SD Gothic Neo"/>
                           <a:ea typeface="Apple SD Gothic Neo"/>
                         </a:rPr>
-                        <a:t>N4 D3 완성 · hold-out 3 1회 판정</a:t>
+                        <a:t>N4 D3 병합 · hold-out 3 1회 판정 (완료)</a:t>
                       </a:r>
                     </a:p>
                   </a:txBody>
@@ -12711,7 +12709,7 @@
                           <a:cs typeface="Apple SD Gothic Neo"/>
                           <a:ea typeface="Apple SD Gothic Neo"/>
                         </a:rPr>
-                        <a:t>거짓 ‘제출 가능’·오수용 0 또는 소유자가 잔여 위험 승인</a:t>
+                        <a:t>거짓 ‘제출 가능’ 0, 주입 0/1,525</a:t>
                       </a:r>
                     </a:p>
                   </a:txBody>
@@ -13106,7 +13104,7 @@
                 <a:cs typeface="Apple SD Gothic Neo"/>
                 <a:ea typeface="Apple SD Gothic Neo"/>
               </a:rPr>
-              <a:t>진행 중 (미병합): D3 개발 데이터 시험에서 스캔 제출 1건당 판단을 막는 항목 5.41 → 2.68.  hold-out 3으로 판정하기 전에는 합치지 않습니다.</a:t>
+              <a:t>완료: D3 병합. hold-out 3 한 번 판정에서 스캔 제출 1건당 확인 항목 7.68 → 4.28, 거짓 ‘제출 가능’ 0건 (n=14, 상한 21%).</a:t>
             </a:r>
           </a:p>
           <a:p>
@@ -13279,7 +13277,7 @@
                 <a:cs typeface="Apple SD Gothic Neo"/>
                 <a:ea typeface="Apple SD Gothic Neo"/>
               </a:rPr>
-              <a:t>ADVS · 중간 발표 2026-10-14</a:t>
+              <a:t>ADVS · 중간 발표 2026-10-15</a:t>
             </a:r>
           </a:p>
         </p:txBody>
@@ -13524,7 +13522,7 @@
                 <a:cs typeface="Apple SD Gothic Neo"/>
                 <a:ea typeface="Apple SD Gothic Neo"/>
               </a:rPr>
-              <a:t>현재 글자층을 검증 없이 믿는 구멍을 직접 확인했습니다. 11월에 신뢰 점검을 추가하며, 위·변조 여부 자체는 발급기관 확인이 필요합니다.</a:t>
+              <a:t>보이지 않는·흰색·초소형 숨은 글자는 읽지 않고 ‘확인 필요’로 표시합니다(조작 705건 중 0건 놓침). 위·변조 여부 자체는 발급기관 확인이 필요합니다.</a:t>
             </a:r>
           </a:p>
         </p:txBody>
@@ -13626,7 +13624,7 @@
                 <a:cs typeface="Apple SD Gothic Neo"/>
                 <a:ea typeface="Apple SD Gothic Neo"/>
               </a:rPr>
-              <a:t>측정한 근거가 없어 10월에는 통합하지 않았고, 11월에 격리 환경에서 같은 문서로 비교한 뒤 12월에 결정합니다.</a:t>
+              <a:t>아직 통합하지 않았습니다. 2차 중간발표에서 같은 데이터로 선택적 검증을 비교한 뒤 12월에 결정합니다.</a:t>
             </a:r>
           </a:p>
         </p:txBody>
@@ -13962,7 +13960,7 @@
                 <a:cs typeface="Apple SD Gothic Neo"/>
                 <a:ea typeface="Apple SD Gothic Neo"/>
               </a:rPr>
-              <a:t>ADVS · 중간 발표 2026-10-14</a:t>
+              <a:t>ADVS · 중간 발표 2026-10-15</a:t>
             </a:r>
           </a:p>
         </p:txBody>
@@ -14836,7 +14834,7 @@
                 <a:cs typeface="Apple SD Gothic Neo"/>
                 <a:ea typeface="Apple SD Gothic Neo"/>
               </a:rPr>
-              <a:t>ADVS · 중간 발표 2026-10-14</a:t>
+              <a:t>ADVS · 중간 발표 2026-10-15</a:t>
             </a:r>
           </a:p>
         </p:txBody>
@@ -15172,7 +15170,7 @@
                 <a:cs typeface="Apple SD Gothic Neo"/>
                 <a:ea typeface="Apple SD Gothic Neo"/>
               </a:rPr>
-              <a:t>PDF 글자층 · OCR</a:t>
+              <a:t>보이는 글자층 · OCR</a:t>
             </a:r>
           </a:p>
         </p:txBody>
@@ -16085,7 +16083,7 @@
                 <a:cs typeface="Apple SD Gothic Neo"/>
                 <a:ea typeface="Apple SD Gothic Neo"/>
               </a:rPr>
-              <a:t>D3(내부 일관성 확인): 구현됐지만 미병합, 진행 중</a:t>
+              <a:t>D3(내부 일관성 확인): 병합 완료, hold-out 3에서 한 번 판정</a:t>
             </a:r>
           </a:p>
         </p:txBody>
@@ -16170,7 +16168,7 @@
                 <a:cs typeface="Apple SD Gothic Neo"/>
                 <a:ea typeface="Apple SD Gothic Neo"/>
               </a:rPr>
-              <a:t>PDF 글자층 신뢰 점검 · 사진 품질 게이트</a:t>
+              <a:t>사진 품질 게이트 (원근 보정 등)</a:t>
             </a:r>
           </a:p>
           <a:p>
@@ -16446,7 +16444,7 @@
                 <a:cs typeface="Apple SD Gothic Neo"/>
                 <a:ea typeface="Apple SD Gothic Neo"/>
               </a:rPr>
-              <a:t>ADVS · 중간 발표 2026-10-14</a:t>
+              <a:t>ADVS · 중간 발표 2026-10-15</a:t>
             </a:r>
           </a:p>
         </p:txBody>
@@ -16700,7 +16698,7 @@
       </p:sp>
       <p:pic>
         <p:nvPicPr>
-          <p:cNvPr id="11" name="Picture 10" descr="hi_banner_D6.png"/>
+          <p:cNvPr id="11" name="Picture 10" descr="hi_banner_D9.png"/>
           <p:cNvPicPr>
             <a:picLocks noChangeAspect="1"/>
           </p:cNvPicPr>
@@ -17170,7 +17168,7 @@
                 <a:cs typeface="Apple SD Gothic Neo"/>
                 <a:ea typeface="Apple SD Gothic Neo"/>
               </a:rPr>
-              <a:t>ADVS · 중간 발표 2026-10-14</a:t>
+              <a:t>ADVS · 중간 발표 2026-10-15</a:t>
             </a:r>
           </a:p>
         </p:txBody>
@@ -17335,7 +17333,7 @@
                 <a:cs typeface="Apple SD Gothic Neo"/>
                 <a:ea typeface="Apple SD Gothic Neo"/>
               </a:rPr>
-              <a:t>주입한 OCR 오류 0 / 474 · 0 / 666</a:t>
+              <a:t>주입한 OCR 오류 5,934건 중 1건</a:t>
             </a:r>
           </a:p>
           <a:p>
@@ -17348,7 +17346,7 @@
               </a:spcBef>
             </a:pPr>
             <a:r>
-              <a:rPr sz="1400" b="0">
+              <a:rPr sz="1300" b="0">
                 <a:solidFill>
                   <a:srgbClr val="1B2433"/>
                 </a:solidFill>
@@ -17356,7 +17354,7 @@
                 <a:cs typeface="Apple SD Gothic Neo"/>
                 <a:ea typeface="Apple SD Gothic Neo"/>
               </a:rPr>
-              <a:t>상한 0.63% · 0.45% (같은 원본 서류에서 만든 사례라 낙관적)</a:t>
+              <a:t>1건 = 알려진 잔여 위험(H14, 소유자 승인). 나머지 3개 세트(hold-out 3 포함)는 0건, 상한 약 0.2% (같은 원본에서 만든 사례라 낙관적)</a:t>
             </a:r>
           </a:p>
         </p:txBody>
@@ -17419,7 +17417,7 @@
                 <a:cs typeface="Apple SD Gothic Neo"/>
                 <a:ea typeface="Apple SD Gothic Neo"/>
               </a:rPr>
-              <a:t>사람 확인 항목: 11.64 → 7.23 / 6.59</a:t>
+              <a:t>사람 확인 항목: 11.64 → 3.73 / 3.09</a:t>
             </a:r>
           </a:p>
           <a:p>
@@ -17440,7 +17438,7 @@
                 <a:cs typeface="Apple SD Gothic Neo"/>
                 <a:ea typeface="Apple SD Gothic Neo"/>
               </a:rPr>
-              <a:t>스캔·사진 제출 1건당, 38–43% 감소. 안전 규칙을 강화해 Phase D(3.82 / 3.55)보다 늘었고 소유자가 승인</a:t>
+              <a:t>스캔·사진 제출 1건당(개발 세트), 68–73% 감소. hold-out 3(한 번 판정): 7.68 / 7.32 → 4.28 / 4.08</a:t>
             </a:r>
           </a:p>
         </p:txBody>
@@ -17592,7 +17590,7 @@
                 <a:cs typeface="Apple SD Gothic Neo"/>
                 <a:ea typeface="Apple SD Gothic Neo"/>
               </a:rPr>
-              <a:t>한계와 병목: 오독이 아니라 ‘확인’, 학생 서류 매핑, 실제 데이터</a:t>
+              <a:t>한계와 병목: 오독이 아니라 ‘확인’, 실제 데이터, 알려진 잔여 위험</a:t>
             </a:r>
           </a:p>
         </p:txBody>
@@ -17674,7 +17672,7 @@
                 <a:cs typeface="Apple SD Gothic Neo"/>
                 <a:ea typeface="Apple SD Gothic Neo"/>
               </a:rPr>
-              <a:t>ADVS · 중간 발표 2026-10-14</a:t>
+              <a:t>ADVS · 중간 발표 2026-10-15</a:t>
             </a:r>
           </a:p>
         </p:txBody>
@@ -17890,7 +17888,7 @@
                           <a:cs typeface="Apple SD Gothic Neo"/>
                           <a:ea typeface="Apple SD Gothic Neo"/>
                         </a:rPr>
-                        <a:t>21/58 · 24/58</a:t>
+                        <a:t>56/58 · 57/58</a:t>
                       </a:r>
                     </a:p>
                   </a:txBody>
@@ -18045,7 +18043,7 @@
                 <a:cs typeface="Apple SD Gothic Neo"/>
                 <a:ea typeface="Apple SD Gothic Neo"/>
               </a:rPr>
-              <a:t>확인된 한계 (11월에 기록·해결)</a:t>
+              <a:t>남은 한계</a:t>
             </a:r>
           </a:p>
           <a:p>
@@ -18067,7 +18065,7 @@
                 <a:cs typeface="Apple SD Gothic Neo"/>
                 <a:ea typeface="Apple SD Gothic Neo"/>
               </a:rPr>
-              <a:t>스캔 제출 22건 중 사람 없이 끝난 것은 1건: 독립 확인 정책 때문</a:t>
+              <a:t>스캔 제출 22건 중 사람 없이 끝난 것은 4건 (v2: 1건): 독립 확인 정책 때문</a:t>
             </a:r>
           </a:p>
           <a:p>
@@ -18089,7 +18087,7 @@
                 <a:cs typeface="Apple SD Gothic Neo"/>
                 <a:ea typeface="Apple SD Gothic Neo"/>
               </a:rPr>
-              <a:t>스캔 대학명 추출 실패 (레이아웃·필드 매핑 결함)</a:t>
+              <a:t>대학명 추출 수정: 21/58 → 56/58. 남은 2건은 ‘교’를 OCR이 잘못 읽은 경우</a:t>
             </a:r>
           </a:p>
           <a:p>
@@ -18133,7 +18131,7 @@
                 <a:cs typeface="Apple SD Gothic Neo"/>
                 <a:ea typeface="Apple SD Gothic Neo"/>
               </a:rPr>
-              <a:t>PDF 글자층을 검증 없이 신뢰: 숨은 텍스트가 화면과 다른 날짜를 넣어도 그대로 읽음 (직접 확인, 11월 수정)</a:t>
+              <a:t>PDF 숨은 글자는 무시하고 ‘확인 필요’로 표시 (조작 705건 중 0건 놓침). 위·변조 여부 자체는 판단하지 못함</a:t>
             </a:r>
           </a:p>
           <a:p>
@@ -18177,7 +18175,7 @@
                 <a:cs typeface="Apple SD Gothic Neo"/>
                 <a:ea typeface="Apple SD Gothic Neo"/>
               </a:rPr>
-              <a:t>hold-out 3은 아직 판정하지 않음</a:t>
+              <a:t>hold-out 3은 한 번만 판정함 (스캔 97.5%, 거짓 ‘제출 가능’ 0건)</a:t>
             </a:r>
           </a:p>
         </p:txBody>
@@ -18218,7 +18216,7 @@
                 <a:cs typeface="Apple SD Gothic Neo"/>
                 <a:ea typeface="Apple SD Gothic Neo"/>
               </a:rPr>
-              <a:t>증거: 인식은 가상 데이터에서 거의 정확합니다. 병목은 ① 독립 확인 ② 대학명 매핑 ③ 실제 데이터 부재.</a:t>
+              <a:t>증거: 인식은 가상 데이터에서 거의 정확합니다. 병목은 ① 독립 확인 ② 실제 데이터 부재 ③ 알려진 잔여 위험(H14).</a:t>
             </a:r>
           </a:p>
         </p:txBody>
@@ -18411,7 +18409,7 @@
                 <a:cs typeface="Apple SD Gothic Neo"/>
                 <a:ea typeface="Apple SD Gothic Neo"/>
               </a:rPr>
-              <a:t>ADVS · 중간 발표 2026-10-14</a:t>
+              <a:t>ADVS · 중간 발표 2026-10-15</a:t>
             </a:r>
           </a:p>
         </p:txBody>
@@ -19090,7 +19088,7 @@
                           <a:cs typeface="Apple SD Gothic Neo"/>
                           <a:ea typeface="Apple SD Gothic Neo"/>
                         </a:rPr>
-                        <a:t>결함을 실측(글자층, 대학명)</a:t>
+                        <a:t>글자층·대학명 결함 수정, D3 병합</a:t>
                       </a:r>
                     </a:p>
                   </a:txBody>
@@ -19138,7 +19136,7 @@
                           <a:cs typeface="Apple SD Gothic Neo"/>
                           <a:ea typeface="Apple SD Gothic Neo"/>
                         </a:rPr>
-                        <a:t>문서화만</a:t>
+                        <a:t>v3에 구현됨</a:t>
                       </a:r>
                     </a:p>
                   </a:txBody>
@@ -19162,7 +19160,7 @@
                           <a:cs typeface="Apple SD Gothic Neo"/>
                           <a:ea typeface="Apple SD Gothic Neo"/>
                         </a:rPr>
-                        <a:t>먼저 구현 → 계속</a:t>
+                        <a:t>측정 확대 → 계속</a:t>
                       </a:r>
                     </a:p>
                   </a:txBody>
@@ -19449,7 +19447,7 @@
                 <a:cs typeface="Apple SD Gothic Neo"/>
                 <a:ea typeface="Apple SD Gothic Neo"/>
               </a:rPr>
-              <a:t>ADVS · 중간 발표 2026-10-14</a:t>
+              <a:t>ADVS · 중간 발표 2026-10-15</a:t>
             </a:r>
           </a:p>
         </p:txBody>
@@ -19575,7 +19573,7 @@
                 <a:cs typeface="Apple SD Gothic Neo"/>
                 <a:ea typeface="Apple SD Gothic Neo"/>
               </a:rPr>
-              <a:t>발표 빌드 고정(재현 시연)</a:t>
+              <a:t>발표 빌드 v3 고정(재현 시연)</a:t>
             </a:r>
           </a:p>
           <a:p>
@@ -19597,7 +19595,7 @@
                 <a:cs typeface="Apple SD Gothic Neo"/>
                 <a:ea typeface="Apple SD Gothic Neo"/>
               </a:rPr>
-              <a:t>문서·슬라이드를 코드와 일치</a:t>
+              <a:t>글자층·대학명 수정, D3 병합</a:t>
             </a:r>
           </a:p>
           <a:p>
@@ -19619,7 +19617,7 @@
                 <a:cs typeface="Apple SD Gothic Neo"/>
                 <a:ea typeface="Apple SD Gothic Neo"/>
               </a:rPr>
-              <a:t>한계·결함 기록</a:t>
+              <a:t>hold-out 3 한 번 판정 완료</a:t>
             </a:r>
           </a:p>
           <a:p>
@@ -19641,7 +19639,7 @@
                 <a:cs typeface="Apple SD Gothic Neo"/>
                 <a:ea typeface="Apple SD Gothic Neo"/>
               </a:rPr>
-              <a:t>실사진 말뭉치 만들기 시작</a:t>
+              <a:t>문서·슬라이드를 코드와 일치</a:t>
             </a:r>
           </a:p>
         </p:txBody>
@@ -19789,7 +19787,7 @@
                 <a:cs typeface="Apple SD Gothic Neo"/>
                 <a:ea typeface="Apple SD Gothic Neo"/>
               </a:rPr>
-              <a:t>PDF 글자층 신뢰 점검</a:t>
+              <a:t>실사진 말뭉치 + 정답</a:t>
             </a:r>
           </a:p>
           <a:p>
@@ -19811,7 +19809,7 @@
                 <a:cs typeface="Apple SD Gothic Neo"/>
                 <a:ea typeface="Apple SD Gothic Neo"/>
               </a:rPr>
-              <a:t>대학명 추출 수정</a:t>
+              <a:t>검토자·관리자 화면, 실제 서류 파일럿</a:t>
             </a:r>
           </a:p>
           <a:p>
@@ -19833,7 +19831,7 @@
                 <a:cs typeface="Apple SD Gothic Neo"/>
                 <a:ea typeface="Apple SD Gothic Neo"/>
               </a:rPr>
-              <a:t>D3 완성 → hold-out 3 1회 판정</a:t>
+              <a:t>잔여 위험(H14) 설계 검토</a:t>
             </a:r>
           </a:p>
           <a:p>
@@ -19855,29 +19853,7 @@
                 <a:cs typeface="Apple SD Gothic Neo"/>
                 <a:ea typeface="Apple SD Gothic Neo"/>
               </a:rPr>
-              <a:t>검토자·관리자 화면, 실제 서류 파일럿</a:t>
-            </a:r>
-          </a:p>
-          <a:p>
-            <a:pPr algn="l" marL="256032" indent="-256032">
-              <a:lnSpc>
-                <a:spcPct val="110000"/>
-              </a:lnSpc>
-              <a:spcBef>
-                <a:spcPts val="700"/>
-              </a:spcBef>
-              <a:buChar char="•"/>
-            </a:pPr>
-            <a:r>
-              <a:rPr sz="1400" b="0">
-                <a:solidFill>
-                  <a:srgbClr val="1B2433"/>
-                </a:solidFill>
-                <a:latin typeface="Helvetica Neue"/>
-                <a:cs typeface="Apple SD Gothic Neo"/>
-                <a:ea typeface="Apple SD Gothic Neo"/>
-              </a:rPr>
-              <a:t>선택: 격리 VLM 비교</a:t>
+              <a:t>2차 중간발표: PaddleOCR-VL 선택적 검증 실험 — 기존 OCR과 동일 데이터로 비교 (정확도, 오류 상관, 자동화 효과, 속도)</a:t>
             </a:r>
           </a:p>
         </p:txBody>
@@ -20346,7 +20322,7 @@
                 <a:cs typeface="Apple SD Gothic Neo"/>
                 <a:ea typeface="Apple SD Gothic Neo"/>
               </a:rPr>
-              <a:t>ADVS · 중간 발표 2026-10-14</a:t>
+              <a:t>ADVS · 중간 발표 2026-10-15</a:t>
             </a:r>
           </a:p>
         </p:txBody>
@@ -20724,7 +20700,7 @@
       </p:sp>
       <p:pic>
         <p:nvPicPr>
-          <p:cNvPr id="13" name="Picture 12" descr="hi_banner_D6.png"/>
+          <p:cNvPr id="13" name="Picture 12" descr="hi_banner_D9.png"/>
           <p:cNvPicPr>
             <a:picLocks noChangeAspect="1"/>
           </p:cNvPicPr>
@@ -20808,7 +20784,7 @@
                 <a:cs typeface="Apple SD Gothic Neo"/>
                 <a:ea typeface="Apple SD Gothic Neo"/>
               </a:rPr>
-              <a:t>예: 스캔 서류의 유효기간 4개 항목 (D6)</a:t>
+              <a:t>예: 스캔 서류의 발급일 2개 항목 (D9)</a:t>
             </a:r>
           </a:p>
         </p:txBody>

</xml_diff>